<commit_message>
Use uploaded staff photos; Gerald teaching photo on his slide
</commit_message>
<xml_diff>
--- a/templates/posts/october/2026-10-05-mon-ig-teachers-day-trading-cards.pptx
+++ b/templates/posts/october/2026-10-05-mon-ig-teachers-day-trading-cards.pptx
@@ -4324,7 +4324,7 @@
       </p:sp>
       <p:pic>
         <p:nvPicPr>
-          <p:cNvPr id="4" name="Picture 3" descr="4511350508822684179.jpg"/>
+          <p:cNvPr id="4" name="Picture 3" descr="7658133130993077371.jpg"/>
           <p:cNvPicPr>
             <a:picLocks noChangeAspect="1"/>
           </p:cNvPicPr>
@@ -6624,7 +6624,7 @@
       </p:sp>
       <p:pic>
         <p:nvPicPr>
-          <p:cNvPr id="4" name="Picture 3" descr="4058738025366184175.jpg"/>
+          <p:cNvPr id="4" name="Picture 3" descr="8596170202528277365.jpg"/>
           <p:cNvPicPr>
             <a:picLocks noChangeAspect="1"/>
           </p:cNvPicPr>
@@ -8924,7 +8924,7 @@
       </p:sp>
       <p:pic>
         <p:nvPicPr>
-          <p:cNvPr id="4" name="Picture 3" descr="3463987928563633322.jpg"/>
+          <p:cNvPr id="4" name="Picture 3" descr="4729525718007545033.jpg"/>
           <p:cNvPicPr>
             <a:picLocks noChangeAspect="1"/>
           </p:cNvPicPr>
@@ -11224,7 +11224,7 @@
       </p:sp>
       <p:pic>
         <p:nvPicPr>
-          <p:cNvPr id="4" name="Picture 3" descr="7897438512424806890.jpg"/>
+          <p:cNvPr id="4" name="Picture 3" descr="5153510539159167184.jpg"/>
           <p:cNvPicPr>
             <a:picLocks noChangeAspect="1"/>
           </p:cNvPicPr>

</xml_diff>

<commit_message>
Nick speaking photo on his post; staff group photo on the Teachers' Day cover
</commit_message>
<xml_diff>
--- a/templates/posts/october/2026-10-05-mon-ig-teachers-day-trading-cards.pptx
+++ b/templates/posts/october/2026-10-05-mon-ig-teachers-day-trading-cards.pptx
@@ -4324,7 +4324,7 @@
       </p:sp>
       <p:pic>
         <p:nvPicPr>
-          <p:cNvPr id="4" name="Picture 3" descr="7658133130993077371.jpg"/>
+          <p:cNvPr id="4" name="Picture 3" descr="1500398814426994648.jpg"/>
           <p:cNvPicPr>
             <a:picLocks noChangeAspect="1"/>
           </p:cNvPicPr>
@@ -6624,7 +6624,7 @@
       </p:sp>
       <p:pic>
         <p:nvPicPr>
-          <p:cNvPr id="4" name="Picture 3" descr="8596170202528277365.jpg"/>
+          <p:cNvPr id="4" name="Picture 3" descr="6785216618101045111.jpg"/>
           <p:cNvPicPr>
             <a:picLocks noChangeAspect="1"/>
           </p:cNvPicPr>
@@ -8924,7 +8924,7 @@
       </p:sp>
       <p:pic>
         <p:nvPicPr>
-          <p:cNvPr id="4" name="Picture 3" descr="4729525718007545033.jpg"/>
+          <p:cNvPr id="4" name="Picture 3" descr="3555897757468015068.jpg"/>
           <p:cNvPicPr>
             <a:picLocks noChangeAspect="1"/>
           </p:cNvPicPr>
@@ -11224,7 +11224,7 @@
       </p:sp>
       <p:pic>
         <p:nvPicPr>
-          <p:cNvPr id="4" name="Picture 3" descr="5153510539159167184.jpg"/>
+          <p:cNvPr id="4" name="Picture 3" descr="8570916478820365395.jpg"/>
           <p:cNvPicPr>
             <a:picLocks noChangeAspect="1"/>
           </p:cNvPicPr>

</xml_diff>